<commit_message>
Añadir respuestas al debate y repaso del día 4 Módulo 4
- 2 slides con respuestas al debate (Trazabilidad en blockchain):
  datos falsos en origen, integración con IoT, verificación por consumidor,
  datos públicos vs Private Data, tokens fungibles vs NFTs para lotes
- 2 slides con respuestas al repaso:
  implementación token fungible, funciones básicas, fungible vs NFT,
  composite keys, flujo trazabilidad lote alimentario, recall, historial

Co-Authored-By: Claude Opus 4.6 (1M context) <noreply@anthropic.com>
</commit_message>
<xml_diff>
--- a/docs/slides/Modulo 4/dia_4.pptx
+++ b/docs/slides/Modulo 4/dia_4.pptx
@@ -27,6 +27,10 @@
     <p:sldId id="275" r:id="rId26"/>
     <p:sldId id="276" r:id="rId27"/>
     <p:sldId id="277" r:id="rId28"/>
+    <p:sldId id="278" r:id="rId29"/>
+    <p:sldId id="279" r:id="rId30"/>
+    <p:sldId id="280" r:id="rId31"/>
+    <p:sldId id="281" r:id="rId32"/>
   </p:sldIdLst>
   <p:sldSz cx="12188952" cy="6858000" type="screen4x3"/>
   <p:notesSz cx="6858000" cy="9144000"/>
@@ -7764,7 +7768,7 @@
         <p:spPr>
           <a:xfrm>
             <a:off x="0" y="0"/>
-            <a:ext cx="12188952" cy="6858000"/>
+            <a:ext cx="12188952" cy="73152"/>
           </a:xfrm>
           <a:prstGeom prst="rect">
             <a:avLst/>
@@ -7819,6 +7823,792 @@
           <a:lstStyle/>
           <a:p>
             <a:pPr algn="l">
+              <a:defRPr sz="3200" b="1">
+                <a:solidFill>
+                  <a:srgbClr val="22627E"/>
+                </a:solidFill>
+                <a:latin typeface="Calibri"/>
+              </a:defRPr>
+            </a:pPr>
+            <a:r>
+              <a:t>Respuestas al debate (1/2)</a:t>
+            </a:r>
+          </a:p>
+        </p:txBody>
+      </p:sp>
+      <p:sp>
+        <p:nvSpPr>
+          <p:cNvPr id="4" name="Rectangle 3"/>
+          <p:cNvSpPr/>
+          <p:nvPr/>
+        </p:nvSpPr>
+        <p:spPr>
+          <a:xfrm>
+            <a:off x="457200" y="1051560"/>
+            <a:ext cx="10972800" cy="27432"/>
+          </a:xfrm>
+          <a:prstGeom prst="rect">
+            <a:avLst/>
+          </a:prstGeom>
+          <a:solidFill>
+            <a:srgbClr val="22627E"/>
+          </a:solidFill>
+          <a:ln>
+            <a:noFill/>
+          </a:ln>
+        </p:spPr>
+        <p:style>
+          <a:lnRef idx="1">
+            <a:schemeClr val="accent1"/>
+          </a:lnRef>
+          <a:fillRef idx="3">
+            <a:schemeClr val="accent1"/>
+          </a:fillRef>
+          <a:effectRef idx="2">
+            <a:schemeClr val="accent1"/>
+          </a:effectRef>
+          <a:fontRef idx="minor">
+            <a:schemeClr val="lt1"/>
+          </a:fontRef>
+        </p:style>
+        <p:txBody>
+          <a:bodyPr rtlCol="0" anchor="ctr"/>
+          <a:lstStyle/>
+          <a:p>
+            <a:pPr algn="ctr"/>
+          </a:p>
+        </p:txBody>
+      </p:sp>
+      <p:sp>
+        <p:nvSpPr>
+          <p:cNvPr id="5" name="TextBox 4"/>
+          <p:cNvSpPr txBox="1"/>
+          <p:nvPr/>
+        </p:nvSpPr>
+        <p:spPr>
+          <a:xfrm>
+            <a:off x="640080" y="1280160"/>
+            <a:ext cx="10515600" cy="5029200"/>
+          </a:xfrm>
+          <a:prstGeom prst="rect">
+            <a:avLst/>
+          </a:prstGeom>
+          <a:noFill/>
+        </p:spPr>
+        <p:txBody>
+          <a:bodyPr wrap="square">
+            <a:spAutoFit/>
+          </a:bodyPr>
+          <a:lstStyle/>
+          <a:p>
+            <a:pPr>
+              <a:spcAft>
+                <a:spcPts val="800"/>
+              </a:spcAft>
+              <a:defRPr sz="2000">
+                <a:solidFill>
+                  <a:srgbClr val="333333"/>
+                </a:solidFill>
+                <a:latin typeface="Calibri"/>
+              </a:defRPr>
+            </a:pPr>
+            <a:r>
+              <a:t>1. Datos falsos en el origen (garbage in, garbage out):</a:t>
+            </a:r>
+          </a:p>
+          <a:p>
+            <a:pPr lvl="1">
+              <a:spcAft>
+                <a:spcPts val="400"/>
+              </a:spcAft>
+              <a:defRPr sz="1700">
+                <a:solidFill>
+                  <a:srgbClr val="666666"/>
+                </a:solidFill>
+                <a:latin typeface="Calibri"/>
+              </a:defRPr>
+            </a:pPr>
+            <a:r>
+              <a:t>    Blockchain garantiza INTEGRIDAD (no modificable una vez registrado), NO VERACIDAD del dato inicial.</a:t>
+            </a:r>
+          </a:p>
+          <a:p>
+            <a:pPr lvl="1">
+              <a:spcAft>
+                <a:spcPts val="400"/>
+              </a:spcAft>
+              <a:defRPr sz="1700">
+                <a:solidFill>
+                  <a:srgbClr val="666666"/>
+                </a:solidFill>
+                <a:latin typeface="Calibri"/>
+              </a:defRPr>
+            </a:pPr>
+            <a:r>
+              <a:t>    Si el productor miente al registrar, la mentira queda inmutable pero sigue siendo mentira.</a:t>
+            </a:r>
+          </a:p>
+          <a:p>
+            <a:pPr lvl="1">
+              <a:spcAft>
+                <a:spcPts val="400"/>
+              </a:spcAft>
+              <a:defRPr sz="1700">
+                <a:solidFill>
+                  <a:srgbClr val="666666"/>
+                </a:solidFill>
+                <a:latin typeface="Calibri"/>
+              </a:defRPr>
+            </a:pPr>
+            <a:r>
+              <a:t>    Mitigaciones: auditorias fisicas, peritajes, validacion cruzada entre actores.</a:t>
+            </a:r>
+          </a:p>
+          <a:p>
+            <a:pPr lvl="1">
+              <a:spcAft>
+                <a:spcPts val="400"/>
+              </a:spcAft>
+              <a:defRPr sz="1700">
+                <a:solidFill>
+                  <a:srgbClr val="666666"/>
+                </a:solidFill>
+                <a:latin typeface="Calibri"/>
+              </a:defRPr>
+            </a:pPr>
+            <a:r>
+              <a:t>    Sensores IoT reducen el problema: datos automaticos, no manuales.</a:t>
+            </a:r>
+          </a:p>
+          <a:p>
+            <a:pPr lvl="1">
+              <a:spcAft>
+                <a:spcPts val="400"/>
+              </a:spcAft>
+              <a:defRPr sz="1700">
+                <a:solidFill>
+                  <a:srgbClr val="666666"/>
+                </a:solidFill>
+                <a:latin typeface="Calibri"/>
+              </a:defRPr>
+            </a:pPr>
+            <a:r>
+              <a:t>    Responsabilidad legal: el certificado identifica a la persona/empresa que firmo el dato.</a:t>
+            </a:r>
+          </a:p>
+          <a:p>
+            <a:pPr>
+              <a:spcAft>
+                <a:spcPts val="800"/>
+              </a:spcAft>
+              <a:defRPr sz="2000">
+                <a:solidFill>
+                  <a:srgbClr val="333333"/>
+                </a:solidFill>
+                <a:latin typeface="Calibri"/>
+              </a:defRPr>
+            </a:pPr>
+            <a:r>
+              <a:t>2. Integracion con IoT (sensores de temperatura):</a:t>
+            </a:r>
+          </a:p>
+          <a:p>
+            <a:pPr lvl="1">
+              <a:spcAft>
+                <a:spcPts val="400"/>
+              </a:spcAft>
+              <a:defRPr sz="1700">
+                <a:solidFill>
+                  <a:srgbClr val="666666"/>
+                </a:solidFill>
+                <a:latin typeface="Calibri"/>
+              </a:defRPr>
+            </a:pPr>
+            <a:r>
+              <a:t>    Los sensores IoT NO se conectan directamente al chaincode (no tienen cert X.509).</a:t>
+            </a:r>
+          </a:p>
+          <a:p>
+            <a:pPr lvl="1">
+              <a:spcAft>
+                <a:spcPts val="400"/>
+              </a:spcAft>
+              <a:defRPr sz="1700">
+                <a:solidFill>
+                  <a:srgbClr val="666666"/>
+                </a:solidFill>
+                <a:latin typeface="Calibri"/>
+              </a:defRPr>
+            </a:pPr>
+            <a:r>
+              <a:t>    Patron: gateway IoT intermedio con certificado, firma y envia al chaincode.</a:t>
+            </a:r>
+          </a:p>
+          <a:p>
+            <a:pPr lvl="1">
+              <a:spcAft>
+                <a:spcPts val="400"/>
+              </a:spcAft>
+              <a:defRPr sz="1700">
+                <a:solidFill>
+                  <a:srgbClr val="666666"/>
+                </a:solidFill>
+                <a:latin typeface="Calibri"/>
+              </a:defRPr>
+            </a:pPr>
+            <a:r>
+              <a:t>    El gateway valida firmas de los sensores (HMAC, TPM) antes de enviar al ledger.</a:t>
+            </a:r>
+          </a:p>
+          <a:p>
+            <a:pPr lvl="1">
+              <a:spcAft>
+                <a:spcPts val="400"/>
+              </a:spcAft>
+              <a:defRPr sz="1700">
+                <a:solidFill>
+                  <a:srgbClr val="666666"/>
+                </a:solidFill>
+                <a:latin typeface="Calibri"/>
+              </a:defRPr>
+            </a:pPr>
+            <a:r>
+              <a:t>    El chaincode solo ve: 'gateway-X certifica que sensor-Y reporto temp=6.5°C a las 10:30'.</a:t>
+            </a:r>
+          </a:p>
+          <a:p>
+            <a:pPr lvl="1">
+              <a:spcAft>
+                <a:spcPts val="400"/>
+              </a:spcAft>
+              <a:defRPr sz="1700">
+                <a:solidFill>
+                  <a:srgbClr val="666666"/>
+                </a:solidFill>
+                <a:latin typeface="Calibri"/>
+              </a:defRPr>
+            </a:pPr>
+            <a:r>
+              <a:t>    Responsabilidad del gateway: garantizar que no manipula los datos antes de enviarlos.</a:t>
+            </a:r>
+          </a:p>
+          <a:p>
+            <a:pPr>
+              <a:spcAft>
+                <a:spcPts val="800"/>
+              </a:spcAft>
+              <a:defRPr sz="2000">
+                <a:solidFill>
+                  <a:srgbClr val="333333"/>
+                </a:solidFill>
+                <a:latin typeface="Calibri"/>
+              </a:defRPr>
+            </a:pPr>
+            <a:r>
+              <a:t>3. Verificacion por el consumidor final sin peer:</a:t>
+            </a:r>
+          </a:p>
+          <a:p>
+            <a:pPr lvl="1">
+              <a:spcAft>
+                <a:spcPts val="400"/>
+              </a:spcAft>
+              <a:defRPr sz="1700">
+                <a:solidFill>
+                  <a:srgbClr val="666666"/>
+                </a:solidFill>
+                <a:latin typeface="Calibri"/>
+              </a:defRPr>
+            </a:pPr>
+            <a:r>
+              <a:t>    El consumidor NO necesita ser org ni tener certificado — es solo un lector.</a:t>
+            </a:r>
+          </a:p>
+          <a:p>
+            <a:pPr lvl="1">
+              <a:spcAft>
+                <a:spcPts val="400"/>
+              </a:spcAft>
+              <a:defRPr sz="1700">
+                <a:solidFill>
+                  <a:srgbClr val="666666"/>
+                </a:solidFill>
+                <a:latin typeface="Calibri"/>
+              </a:defRPr>
+            </a:pPr>
+            <a:r>
+              <a:t>    Patron habitual: QR en el producto -&gt; web publica del consorcio -&gt; API REST -&gt; chaincode query.</a:t>
+            </a:r>
+          </a:p>
+          <a:p>
+            <a:pPr lvl="1">
+              <a:spcAft>
+                <a:spcPts val="400"/>
+              </a:spcAft>
+              <a:defRPr sz="1700">
+                <a:solidFill>
+                  <a:srgbClr val="666666"/>
+                </a:solidFill>
+                <a:latin typeface="Calibri"/>
+              </a:defRPr>
+            </a:pPr>
+            <a:r>
+              <a:t>    La web usa una identidad de 'lector publico' con permisos de solo consulta.</a:t>
+            </a:r>
+          </a:p>
+          <a:p>
+            <a:pPr lvl="1">
+              <a:spcAft>
+                <a:spcPts val="400"/>
+              </a:spcAft>
+              <a:defRPr sz="1700">
+                <a:solidFill>
+                  <a:srgbClr val="666666"/>
+                </a:solidFill>
+                <a:latin typeface="Calibri"/>
+              </a:defRPr>
+            </a:pPr>
+            <a:r>
+              <a:t>    El consumidor ve el historial pero no puede modificar nada.</a:t>
+            </a:r>
+          </a:p>
+          <a:p>
+            <a:pPr lvl="1">
+              <a:spcAft>
+                <a:spcPts val="400"/>
+              </a:spcAft>
+              <a:defRPr sz="1700">
+                <a:solidFill>
+                  <a:srgbClr val="666666"/>
+                </a:solidFill>
+                <a:latin typeface="Calibri"/>
+              </a:defRPr>
+            </a:pPr>
+            <a:r>
+              <a:t>    Ejemplo real: Carrefour, Walmart — QR en envase con historial completo.</a:t>
+            </a:r>
+          </a:p>
+        </p:txBody>
+      </p:sp>
+    </p:spTree>
+  </p:cSld>
+  <p:clrMapOvr>
+    <a:masterClrMapping/>
+  </p:clrMapOvr>
+</p:sld>
+</file>
+
+<file path=ppt/slides/slide23.xml><?xml version="1.0" encoding="utf-8"?>
+<p:sld xmlns:a="http://schemas.openxmlformats.org/drawingml/2006/main" xmlns:p="http://schemas.openxmlformats.org/presentationml/2006/main" xmlns:r="http://schemas.openxmlformats.org/officeDocument/2006/relationships">
+  <p:cSld>
+    <p:spTree>
+      <p:nvGrpSpPr>
+        <p:cNvPr id="1" name=""/>
+        <p:cNvGrpSpPr/>
+        <p:nvPr/>
+      </p:nvGrpSpPr>
+      <p:grpSpPr/>
+      <p:sp>
+        <p:nvSpPr>
+          <p:cNvPr id="2" name="Rectangle 1"/>
+          <p:cNvSpPr/>
+          <p:nvPr/>
+        </p:nvSpPr>
+        <p:spPr>
+          <a:xfrm>
+            <a:off x="0" y="0"/>
+            <a:ext cx="12188952" cy="73152"/>
+          </a:xfrm>
+          <a:prstGeom prst="rect">
+            <a:avLst/>
+          </a:prstGeom>
+          <a:solidFill>
+            <a:srgbClr val="22627E"/>
+          </a:solidFill>
+          <a:ln>
+            <a:noFill/>
+          </a:ln>
+        </p:spPr>
+        <p:style>
+          <a:lnRef idx="1">
+            <a:schemeClr val="accent1"/>
+          </a:lnRef>
+          <a:fillRef idx="3">
+            <a:schemeClr val="accent1"/>
+          </a:fillRef>
+          <a:effectRef idx="2">
+            <a:schemeClr val="accent1"/>
+          </a:effectRef>
+          <a:fontRef idx="minor">
+            <a:schemeClr val="lt1"/>
+          </a:fontRef>
+        </p:style>
+        <p:txBody>
+          <a:bodyPr rtlCol="0" anchor="ctr"/>
+          <a:lstStyle/>
+          <a:p>
+            <a:pPr algn="ctr"/>
+          </a:p>
+        </p:txBody>
+      </p:sp>
+      <p:sp>
+        <p:nvSpPr>
+          <p:cNvPr id="3" name="TextBox 2"/>
+          <p:cNvSpPr txBox="1"/>
+          <p:nvPr/>
+        </p:nvSpPr>
+        <p:spPr>
+          <a:xfrm>
+            <a:off x="457200" y="274320"/>
+            <a:ext cx="10972800" cy="731520"/>
+          </a:xfrm>
+          <a:prstGeom prst="rect">
+            <a:avLst/>
+          </a:prstGeom>
+          <a:noFill/>
+        </p:spPr>
+        <p:txBody>
+          <a:bodyPr wrap="square"/>
+          <a:lstStyle/>
+          <a:p>
+            <a:pPr algn="l">
+              <a:defRPr sz="3200" b="1">
+                <a:solidFill>
+                  <a:srgbClr val="22627E"/>
+                </a:solidFill>
+                <a:latin typeface="Calibri"/>
+              </a:defRPr>
+            </a:pPr>
+            <a:r>
+              <a:t>Respuestas al debate (2/2)</a:t>
+            </a:r>
+          </a:p>
+        </p:txBody>
+      </p:sp>
+      <p:sp>
+        <p:nvSpPr>
+          <p:cNvPr id="4" name="Rectangle 3"/>
+          <p:cNvSpPr/>
+          <p:nvPr/>
+        </p:nvSpPr>
+        <p:spPr>
+          <a:xfrm>
+            <a:off x="457200" y="1051560"/>
+            <a:ext cx="10972800" cy="27432"/>
+          </a:xfrm>
+          <a:prstGeom prst="rect">
+            <a:avLst/>
+          </a:prstGeom>
+          <a:solidFill>
+            <a:srgbClr val="22627E"/>
+          </a:solidFill>
+          <a:ln>
+            <a:noFill/>
+          </a:ln>
+        </p:spPr>
+        <p:style>
+          <a:lnRef idx="1">
+            <a:schemeClr val="accent1"/>
+          </a:lnRef>
+          <a:fillRef idx="3">
+            <a:schemeClr val="accent1"/>
+          </a:fillRef>
+          <a:effectRef idx="2">
+            <a:schemeClr val="accent1"/>
+          </a:effectRef>
+          <a:fontRef idx="minor">
+            <a:schemeClr val="lt1"/>
+          </a:fontRef>
+        </p:style>
+        <p:txBody>
+          <a:bodyPr rtlCol="0" anchor="ctr"/>
+          <a:lstStyle/>
+          <a:p>
+            <a:pPr algn="ctr"/>
+          </a:p>
+        </p:txBody>
+      </p:sp>
+      <p:sp>
+        <p:nvSpPr>
+          <p:cNvPr id="5" name="TextBox 4"/>
+          <p:cNvSpPr txBox="1"/>
+          <p:nvPr/>
+        </p:nvSpPr>
+        <p:spPr>
+          <a:xfrm>
+            <a:off x="640080" y="1280160"/>
+            <a:ext cx="10515600" cy="5029200"/>
+          </a:xfrm>
+          <a:prstGeom prst="rect">
+            <a:avLst/>
+          </a:prstGeom>
+          <a:noFill/>
+        </p:spPr>
+        <p:txBody>
+          <a:bodyPr wrap="square">
+            <a:spAutoFit/>
+          </a:bodyPr>
+          <a:lstStyle/>
+          <a:p>
+            <a:pPr>
+              <a:spcAft>
+                <a:spcPts val="800"/>
+              </a:spcAft>
+              <a:defRPr sz="2000">
+                <a:solidFill>
+                  <a:srgbClr val="333333"/>
+                </a:solidFill>
+                <a:latin typeface="Calibri"/>
+              </a:defRPr>
+            </a:pPr>
+            <a:r>
+              <a:t>4. Datos publicos vs Private Data en trazabilidad:</a:t>
+            </a:r>
+          </a:p>
+          <a:p>
+            <a:pPr lvl="1">
+              <a:spcAft>
+                <a:spcPts val="400"/>
+              </a:spcAft>
+              <a:defRPr sz="1700">
+                <a:solidFill>
+                  <a:srgbClr val="666666"/>
+                </a:solidFill>
+                <a:latin typeface="Calibri"/>
+              </a:defRPr>
+            </a:pPr>
+            <a:r>
+              <a:t>    Publicos (ledger del canal): ID del lote, origen, fechas, movimientos, status.</a:t>
+            </a:r>
+          </a:p>
+          <a:p>
+            <a:pPr lvl="1">
+              <a:spcAft>
+                <a:spcPts val="400"/>
+              </a:spcAft>
+              <a:defRPr sz="1700">
+                <a:solidFill>
+                  <a:srgbClr val="666666"/>
+                </a:solidFill>
+                <a:latin typeface="Calibri"/>
+              </a:defRPr>
+            </a:pPr>
+            <a:r>
+              <a:t>    La trazabilidad NECESITA ser publica entre miembros del consorcio (es su razon de ser).</a:t>
+            </a:r>
+          </a:p>
+          <a:p>
+            <a:pPr lvl="1">
+              <a:spcAft>
+                <a:spcPts val="400"/>
+              </a:spcAft>
+              <a:defRPr sz="1700">
+                <a:solidFill>
+                  <a:srgbClr val="666666"/>
+                </a:solidFill>
+                <a:latin typeface="Calibri"/>
+              </a:defRPr>
+            </a:pPr>
+            <a:r>
+              <a:t>    Privados (Private Data): precios entre actores, margenes, terminos comerciales.</a:t>
+            </a:r>
+          </a:p>
+          <a:p>
+            <a:pPr lvl="1">
+              <a:spcAft>
+                <a:spcPts val="400"/>
+              </a:spcAft>
+              <a:defRPr sz="1700">
+                <a:solidFill>
+                  <a:srgbClr val="666666"/>
+                </a:solidFill>
+                <a:latin typeface="Calibri"/>
+              </a:defRPr>
+            </a:pPr>
+            <a:r>
+              <a:t>    Datos del consumidor final: OFF-CHAIN (solo hash si hace falta) — cumplimiento GDPR.</a:t>
+            </a:r>
+          </a:p>
+          <a:p>
+            <a:pPr>
+              <a:spcAft>
+                <a:spcPts val="800"/>
+              </a:spcAft>
+              <a:defRPr sz="2000">
+                <a:solidFill>
+                  <a:srgbClr val="333333"/>
+                </a:solidFill>
+                <a:latin typeface="Calibri"/>
+              </a:defRPr>
+            </a:pPr>
+            <a:r>
+              <a:t>5. Tokens fungibles vs NFTs para productos alimentarios:</a:t>
+            </a:r>
+          </a:p>
+          <a:p>
+            <a:pPr lvl="1">
+              <a:spcAft>
+                <a:spcPts val="400"/>
+              </a:spcAft>
+              <a:defRPr sz="1700">
+                <a:solidFill>
+                  <a:srgbClr val="666666"/>
+                </a:solidFill>
+                <a:latin typeface="Calibri"/>
+              </a:defRPr>
+            </a:pPr>
+            <a:r>
+              <a:t>    Un lote alimentario es UNICO: cada batch tiene su propia historia, temperatura, origen.</a:t>
+            </a:r>
+          </a:p>
+          <a:p>
+            <a:pPr lvl="1">
+              <a:spcAft>
+                <a:spcPts val="400"/>
+              </a:spcAft>
+              <a:defRPr sz="1700">
+                <a:solidFill>
+                  <a:srgbClr val="666666"/>
+                </a:solidFill>
+                <a:latin typeface="Calibri"/>
+              </a:defRPr>
+            </a:pPr>
+            <a:r>
+              <a:t>    NFT por lote es lo logico: composite key 'lot~productType~origin~id', metadata propia.</a:t>
+            </a:r>
+          </a:p>
+          <a:p>
+            <a:pPr lvl="1">
+              <a:spcAft>
+                <a:spcPts val="400"/>
+              </a:spcAft>
+              <a:defRPr sz="1700">
+                <a:solidFill>
+                  <a:srgbClr val="666666"/>
+                </a:solidFill>
+                <a:latin typeface="Calibri"/>
+              </a:defRPr>
+            </a:pPr>
+            <a:r>
+              <a:t>    Tokens fungibles tendrian sentido solo si tratas todo el producto como identico (granel).</a:t>
+            </a:r>
+          </a:p>
+          <a:p>
+            <a:pPr lvl="1">
+              <a:spcAft>
+                <a:spcPts val="400"/>
+              </a:spcAft>
+              <a:defRPr sz="1700">
+                <a:solidFill>
+                  <a:srgbClr val="666666"/>
+                </a:solidFill>
+                <a:latin typeface="Calibri"/>
+              </a:defRPr>
+            </a:pPr>
+            <a:r>
+              <a:t>    Mixto: NFT para el lote + tokens fungibles para representar kilos extraidos del lote.</a:t>
+            </a:r>
+          </a:p>
+          <a:p>
+            <a:pPr lvl="1">
+              <a:spcAft>
+                <a:spcPts val="400"/>
+              </a:spcAft>
+              <a:defRPr sz="1700">
+                <a:solidFill>
+                  <a:srgbClr val="666666"/>
+                </a:solidFill>
+                <a:latin typeface="Calibri"/>
+              </a:defRPr>
+            </a:pPr>
+            <a:r>
+              <a:t>    Cuando el supermercado 'reparte' un lote en multiples envases, cada envase puede ser fungible.</a:t>
+            </a:r>
+          </a:p>
+        </p:txBody>
+      </p:sp>
+    </p:spTree>
+  </p:cSld>
+  <p:clrMapOvr>
+    <a:masterClrMapping/>
+  </p:clrMapOvr>
+</p:sld>
+</file>
+
+<file path=ppt/slides/slide24.xml><?xml version="1.0" encoding="utf-8"?>
+<p:sld xmlns:a="http://schemas.openxmlformats.org/drawingml/2006/main" xmlns:p="http://schemas.openxmlformats.org/presentationml/2006/main" xmlns:r="http://schemas.openxmlformats.org/officeDocument/2006/relationships">
+  <p:cSld>
+    <p:spTree>
+      <p:nvGrpSpPr>
+        <p:cNvPr id="1" name=""/>
+        <p:cNvGrpSpPr/>
+        <p:nvPr/>
+      </p:nvGrpSpPr>
+      <p:grpSpPr/>
+      <p:sp>
+        <p:nvSpPr>
+          <p:cNvPr id="2" name="Rectangle 1"/>
+          <p:cNvSpPr/>
+          <p:nvPr/>
+        </p:nvSpPr>
+        <p:spPr>
+          <a:xfrm>
+            <a:off x="0" y="0"/>
+            <a:ext cx="12188952" cy="6858000"/>
+          </a:xfrm>
+          <a:prstGeom prst="rect">
+            <a:avLst/>
+          </a:prstGeom>
+          <a:solidFill>
+            <a:srgbClr val="22627E"/>
+          </a:solidFill>
+          <a:ln>
+            <a:noFill/>
+          </a:ln>
+        </p:spPr>
+        <p:style>
+          <a:lnRef idx="1">
+            <a:schemeClr val="accent1"/>
+          </a:lnRef>
+          <a:fillRef idx="3">
+            <a:schemeClr val="accent1"/>
+          </a:fillRef>
+          <a:effectRef idx="2">
+            <a:schemeClr val="accent1"/>
+          </a:effectRef>
+          <a:fontRef idx="minor">
+            <a:schemeClr val="lt1"/>
+          </a:fontRef>
+        </p:style>
+        <p:txBody>
+          <a:bodyPr rtlCol="0" anchor="ctr"/>
+          <a:lstStyle/>
+          <a:p>
+            <a:pPr algn="ctr"/>
+          </a:p>
+        </p:txBody>
+      </p:sp>
+      <p:sp>
+        <p:nvSpPr>
+          <p:cNvPr id="3" name="TextBox 2"/>
+          <p:cNvSpPr txBox="1"/>
+          <p:nvPr/>
+        </p:nvSpPr>
+        <p:spPr>
+          <a:xfrm>
+            <a:off x="457200" y="274320"/>
+            <a:ext cx="10972800" cy="731520"/>
+          </a:xfrm>
+          <a:prstGeom prst="rect">
+            <a:avLst/>
+          </a:prstGeom>
+          <a:noFill/>
+        </p:spPr>
+        <p:txBody>
+          <a:bodyPr wrap="square"/>
+          <a:lstStyle/>
+          <a:p>
+            <a:pPr algn="l">
               <a:defRPr sz="3600" b="1">
                 <a:solidFill>
                   <a:srgbClr val="FFFFFF"/>
@@ -8006,6 +8796,968 @@
             </a:pPr>
             <a:r>
               <a:t>7. ¿Como se registra el historial de movimientos de un lote?</a:t>
+            </a:r>
+          </a:p>
+        </p:txBody>
+      </p:sp>
+    </p:spTree>
+  </p:cSld>
+  <p:clrMapOvr>
+    <a:masterClrMapping/>
+  </p:clrMapOvr>
+</p:sld>
+</file>
+
+<file path=ppt/slides/slide25.xml><?xml version="1.0" encoding="utf-8"?>
+<p:sld xmlns:a="http://schemas.openxmlformats.org/drawingml/2006/main" xmlns:p="http://schemas.openxmlformats.org/presentationml/2006/main" xmlns:r="http://schemas.openxmlformats.org/officeDocument/2006/relationships">
+  <p:cSld>
+    <p:spTree>
+      <p:nvGrpSpPr>
+        <p:cNvPr id="1" name=""/>
+        <p:cNvGrpSpPr/>
+        <p:nvPr/>
+      </p:nvGrpSpPr>
+      <p:grpSpPr/>
+      <p:sp>
+        <p:nvSpPr>
+          <p:cNvPr id="2" name="Rectangle 1"/>
+          <p:cNvSpPr/>
+          <p:nvPr/>
+        </p:nvSpPr>
+        <p:spPr>
+          <a:xfrm>
+            <a:off x="0" y="0"/>
+            <a:ext cx="12188952" cy="73152"/>
+          </a:xfrm>
+          <a:prstGeom prst="rect">
+            <a:avLst/>
+          </a:prstGeom>
+          <a:solidFill>
+            <a:srgbClr val="22627E"/>
+          </a:solidFill>
+          <a:ln>
+            <a:noFill/>
+          </a:ln>
+        </p:spPr>
+        <p:style>
+          <a:lnRef idx="1">
+            <a:schemeClr val="accent1"/>
+          </a:lnRef>
+          <a:fillRef idx="3">
+            <a:schemeClr val="accent1"/>
+          </a:fillRef>
+          <a:effectRef idx="2">
+            <a:schemeClr val="accent1"/>
+          </a:effectRef>
+          <a:fontRef idx="minor">
+            <a:schemeClr val="lt1"/>
+          </a:fontRef>
+        </p:style>
+        <p:txBody>
+          <a:bodyPr rtlCol="0" anchor="ctr"/>
+          <a:lstStyle/>
+          <a:p>
+            <a:pPr algn="ctr"/>
+          </a:p>
+        </p:txBody>
+      </p:sp>
+      <p:sp>
+        <p:nvSpPr>
+          <p:cNvPr id="3" name="TextBox 2"/>
+          <p:cNvSpPr txBox="1"/>
+          <p:nvPr/>
+        </p:nvSpPr>
+        <p:spPr>
+          <a:xfrm>
+            <a:off x="457200" y="274320"/>
+            <a:ext cx="10972800" cy="731520"/>
+          </a:xfrm>
+          <a:prstGeom prst="rect">
+            <a:avLst/>
+          </a:prstGeom>
+          <a:noFill/>
+        </p:spPr>
+        <p:txBody>
+          <a:bodyPr wrap="square"/>
+          <a:lstStyle/>
+          <a:p>
+            <a:pPr algn="l">
+              <a:defRPr sz="3200" b="1">
+                <a:solidFill>
+                  <a:srgbClr val="22627E"/>
+                </a:solidFill>
+                <a:latin typeface="Calibri"/>
+              </a:defRPr>
+            </a:pPr>
+            <a:r>
+              <a:t>Respuestas al repaso (1/2)</a:t>
+            </a:r>
+          </a:p>
+        </p:txBody>
+      </p:sp>
+      <p:sp>
+        <p:nvSpPr>
+          <p:cNvPr id="4" name="Rectangle 3"/>
+          <p:cNvSpPr/>
+          <p:nvPr/>
+        </p:nvSpPr>
+        <p:spPr>
+          <a:xfrm>
+            <a:off x="457200" y="1051560"/>
+            <a:ext cx="10972800" cy="27432"/>
+          </a:xfrm>
+          <a:prstGeom prst="rect">
+            <a:avLst/>
+          </a:prstGeom>
+          <a:solidFill>
+            <a:srgbClr val="22627E"/>
+          </a:solidFill>
+          <a:ln>
+            <a:noFill/>
+          </a:ln>
+        </p:spPr>
+        <p:style>
+          <a:lnRef idx="1">
+            <a:schemeClr val="accent1"/>
+          </a:lnRef>
+          <a:fillRef idx="3">
+            <a:schemeClr val="accent1"/>
+          </a:fillRef>
+          <a:effectRef idx="2">
+            <a:schemeClr val="accent1"/>
+          </a:effectRef>
+          <a:fontRef idx="minor">
+            <a:schemeClr val="lt1"/>
+          </a:fontRef>
+        </p:style>
+        <p:txBody>
+          <a:bodyPr rtlCol="0" anchor="ctr"/>
+          <a:lstStyle/>
+          <a:p>
+            <a:pPr algn="ctr"/>
+          </a:p>
+        </p:txBody>
+      </p:sp>
+      <p:sp>
+        <p:nvSpPr>
+          <p:cNvPr id="5" name="TextBox 4"/>
+          <p:cNvSpPr txBox="1"/>
+          <p:nvPr/>
+        </p:nvSpPr>
+        <p:spPr>
+          <a:xfrm>
+            <a:off x="640080" y="1280160"/>
+            <a:ext cx="10515600" cy="5029200"/>
+          </a:xfrm>
+          <a:prstGeom prst="rect">
+            <a:avLst/>
+          </a:prstGeom>
+          <a:noFill/>
+        </p:spPr>
+        <p:txBody>
+          <a:bodyPr wrap="square">
+            <a:spAutoFit/>
+          </a:bodyPr>
+          <a:lstStyle/>
+          <a:p>
+            <a:pPr>
+              <a:spcAft>
+                <a:spcPts val="800"/>
+              </a:spcAft>
+              <a:defRPr sz="2000">
+                <a:solidFill>
+                  <a:srgbClr val="333333"/>
+                </a:solidFill>
+                <a:latin typeface="Calibri"/>
+              </a:defRPr>
+            </a:pPr>
+            <a:r>
+              <a:t>1. Implementar un token fungible en Fabric:</a:t>
+            </a:r>
+          </a:p>
+          <a:p>
+            <a:pPr lvl="1">
+              <a:spcAft>
+                <a:spcPts val="400"/>
+              </a:spcAft>
+              <a:defRPr sz="1700">
+                <a:solidFill>
+                  <a:srgbClr val="666666"/>
+                </a:solidFill>
+                <a:latin typeface="Calibri"/>
+              </a:defRPr>
+            </a:pPr>
+            <a:r>
+              <a:t>    Chaincode con un mapping balance por cliente (clientID -&gt; cantidad).</a:t>
+            </a:r>
+          </a:p>
+          <a:p>
+            <a:pPr lvl="1">
+              <a:spcAft>
+                <a:spcPts val="400"/>
+              </a:spcAft>
+              <a:defRPr sz="1700">
+                <a:solidFill>
+                  <a:srgbClr val="666666"/>
+                </a:solidFill>
+                <a:latin typeface="Calibri"/>
+              </a:defRPr>
+            </a:pPr>
+            <a:r>
+              <a:t>    PutState('balance~' + clientID, amount) para cada propietario.</a:t>
+            </a:r>
+          </a:p>
+          <a:p>
+            <a:pPr lvl="1">
+              <a:spcAft>
+                <a:spcPts val="400"/>
+              </a:spcAft>
+              <a:defRPr sz="1700">
+                <a:solidFill>
+                  <a:srgbClr val="666666"/>
+                </a:solidFill>
+                <a:latin typeface="Calibri"/>
+              </a:defRPr>
+            </a:pPr>
+            <a:r>
+              <a:t>    Otra estructura para totalSupply global y metadata del token.</a:t>
+            </a:r>
+          </a:p>
+          <a:p>
+            <a:pPr lvl="1">
+              <a:spcAft>
+                <a:spcPts val="400"/>
+              </a:spcAft>
+              <a:defRPr sz="1700">
+                <a:solidFill>
+                  <a:srgbClr val="666666"/>
+                </a:solidFill>
+                <a:latin typeface="Calibri"/>
+              </a:defRPr>
+            </a:pPr>
+            <a:r>
+              <a:t>    Tres opciones: custom desde cero, Fabric Token SDK, fabric-samples/token-erc-20.</a:t>
+            </a:r>
+          </a:p>
+          <a:p>
+            <a:pPr>
+              <a:spcAft>
+                <a:spcPts val="800"/>
+              </a:spcAft>
+              <a:defRPr sz="2000">
+                <a:solidFill>
+                  <a:srgbClr val="333333"/>
+                </a:solidFill>
+                <a:latin typeface="Calibri"/>
+              </a:defRPr>
+            </a:pPr>
+            <a:r>
+              <a:t>2. Funciones basicas del token fungible:</a:t>
+            </a:r>
+          </a:p>
+          <a:p>
+            <a:pPr lvl="1">
+              <a:spcAft>
+                <a:spcPts val="400"/>
+              </a:spcAft>
+              <a:defRPr sz="1700">
+                <a:solidFill>
+                  <a:srgbClr val="666666"/>
+                </a:solidFill>
+                <a:latin typeface="Calibri"/>
+              </a:defRPr>
+            </a:pPr>
+            <a:r>
+              <a:t>    Mint(to, amount): crear tokens (solo el emisor autorizado).</a:t>
+            </a:r>
+          </a:p>
+          <a:p>
+            <a:pPr lvl="1">
+              <a:spcAft>
+                <a:spcPts val="400"/>
+              </a:spcAft>
+              <a:defRPr sz="1700">
+                <a:solidFill>
+                  <a:srgbClr val="666666"/>
+                </a:solidFill>
+                <a:latin typeface="Calibri"/>
+              </a:defRPr>
+            </a:pPr>
+            <a:r>
+              <a:t>    Burn(from, amount): destruir tokens propios o del sistema.</a:t>
+            </a:r>
+          </a:p>
+          <a:p>
+            <a:pPr lvl="1">
+              <a:spcAft>
+                <a:spcPts val="400"/>
+              </a:spcAft>
+              <a:defRPr sz="1700">
+                <a:solidFill>
+                  <a:srgbClr val="666666"/>
+                </a:solidFill>
+                <a:latin typeface="Calibri"/>
+              </a:defRPr>
+            </a:pPr>
+            <a:r>
+              <a:t>    Transfer(to, amount): enviar del caller al destinatario.</a:t>
+            </a:r>
+          </a:p>
+          <a:p>
+            <a:pPr lvl="1">
+              <a:spcAft>
+                <a:spcPts val="400"/>
+              </a:spcAft>
+              <a:defRPr sz="1700">
+                <a:solidFill>
+                  <a:srgbClr val="666666"/>
+                </a:solidFill>
+                <a:latin typeface="Calibri"/>
+              </a:defRPr>
+            </a:pPr>
+            <a:r>
+              <a:t>    BalanceOf(account): consultar saldo.</a:t>
+            </a:r>
+          </a:p>
+          <a:p>
+            <a:pPr lvl="1">
+              <a:spcAft>
+                <a:spcPts val="400"/>
+              </a:spcAft>
+              <a:defRPr sz="1700">
+                <a:solidFill>
+                  <a:srgbClr val="666666"/>
+                </a:solidFill>
+                <a:latin typeface="Calibri"/>
+              </a:defRPr>
+            </a:pPr>
+            <a:r>
+              <a:t>    Approve(spender, amount) + TransferFrom: delegacion.</a:t>
+            </a:r>
+          </a:p>
+          <a:p>
+            <a:pPr lvl="1">
+              <a:spcAft>
+                <a:spcPts val="400"/>
+              </a:spcAft>
+              <a:defRPr sz="1700">
+                <a:solidFill>
+                  <a:srgbClr val="666666"/>
+                </a:solidFill>
+                <a:latin typeface="Calibri"/>
+              </a:defRPr>
+            </a:pPr>
+            <a:r>
+              <a:t>    TotalSupply(): supply total en circulacion.</a:t>
+            </a:r>
+          </a:p>
+          <a:p>
+            <a:pPr>
+              <a:spcAft>
+                <a:spcPts val="800"/>
+              </a:spcAft>
+              <a:defRPr sz="2000">
+                <a:solidFill>
+                  <a:srgbClr val="333333"/>
+                </a:solidFill>
+                <a:latin typeface="Calibri"/>
+              </a:defRPr>
+            </a:pPr>
+            <a:r>
+              <a:t>3. Token fungible vs no fungible en Fabric:</a:t>
+            </a:r>
+          </a:p>
+          <a:p>
+            <a:pPr lvl="1">
+              <a:spcAft>
+                <a:spcPts val="400"/>
+              </a:spcAft>
+              <a:defRPr sz="1700">
+                <a:solidFill>
+                  <a:srgbClr val="666666"/>
+                </a:solidFill>
+                <a:latin typeface="Calibri"/>
+              </a:defRPr>
+            </a:pPr>
+            <a:r>
+              <a:t>    Fungible: cada token es identico e intercambiable (1 FP vale igual que cualquier otro 1 FP).</a:t>
+            </a:r>
+          </a:p>
+          <a:p>
+            <a:pPr lvl="1">
+              <a:spcAft>
+                <a:spcPts val="400"/>
+              </a:spcAft>
+              <a:defRPr sz="1700">
+                <a:solidFill>
+                  <a:srgbClr val="666666"/>
+                </a:solidFill>
+                <a:latin typeface="Calibri"/>
+              </a:defRPr>
+            </a:pPr>
+            <a:r>
+              <a:t>    No fungible: cada token tiene identidad unica (tokenID, metadata propia).</a:t>
+            </a:r>
+          </a:p>
+          <a:p>
+            <a:pPr lvl="1">
+              <a:spcAft>
+                <a:spcPts val="400"/>
+              </a:spcAft>
+              <a:defRPr sz="1700">
+                <a:solidFill>
+                  <a:srgbClr val="666666"/>
+                </a:solidFill>
+                <a:latin typeface="Calibri"/>
+              </a:defRPr>
+            </a:pPr>
+            <a:r>
+              <a:t>    Fungible: balance por cuenta. NFT: registro por tokenID con metadata.</a:t>
+            </a:r>
+          </a:p>
+          <a:p>
+            <a:pPr lvl="1">
+              <a:spcAft>
+                <a:spcPts val="400"/>
+              </a:spcAft>
+              <a:defRPr sz="1700">
+                <a:solidFill>
+                  <a:srgbClr val="666666"/>
+                </a:solidFill>
+                <a:latin typeface="Calibri"/>
+              </a:defRPr>
+            </a:pPr>
+            <a:r>
+              <a:t>    NFT: composite key 'nft~owner~tokenID' permite buscar por dueno.</a:t>
+            </a:r>
+          </a:p>
+          <a:p>
+            <a:pPr>
+              <a:spcAft>
+                <a:spcPts val="800"/>
+              </a:spcAft>
+              <a:defRPr sz="2000">
+                <a:solidFill>
+                  <a:srgbClr val="333333"/>
+                </a:solidFill>
+                <a:latin typeface="Calibri"/>
+              </a:defRPr>
+            </a:pPr>
+            <a:r>
+              <a:t>4. Composite keys en NFTs:</a:t>
+            </a:r>
+          </a:p>
+          <a:p>
+            <a:pPr lvl="1">
+              <a:spcAft>
+                <a:spcPts val="400"/>
+              </a:spcAft>
+              <a:defRPr sz="1700">
+                <a:solidFill>
+                  <a:srgbClr val="666666"/>
+                </a:solidFill>
+                <a:latin typeface="Calibri"/>
+              </a:defRPr>
+            </a:pPr>
+            <a:r>
+              <a:t>    Key = prefijo (tipo de objeto) + atributos (owner, categoria, id).</a:t>
+            </a:r>
+          </a:p>
+          <a:p>
+            <a:pPr lvl="1">
+              <a:spcAft>
+                <a:spcPts val="400"/>
+              </a:spcAft>
+              <a:defRPr sz="1700">
+                <a:solidFill>
+                  <a:srgbClr val="666666"/>
+                </a:solidFill>
+                <a:latin typeface="Calibri"/>
+              </a:defRPr>
+            </a:pPr>
+            <a:r>
+              <a:t>    Permite GetStateByPartialCompositeKey — buscar por prefijo sin recorrer todo.</a:t>
+            </a:r>
+          </a:p>
+          <a:p>
+            <a:pPr lvl="1">
+              <a:spcAft>
+                <a:spcPts val="400"/>
+              </a:spcAft>
+              <a:defRPr sz="1700">
+                <a:solidFill>
+                  <a:srgbClr val="666666"/>
+                </a:solidFill>
+                <a:latin typeface="Calibri"/>
+              </a:defRPr>
+            </a:pPr>
+            <a:r>
+              <a:t>    Ejemplo: 'nft~alice~*' devuelve todos los NFTs de Alice.</a:t>
+            </a:r>
+          </a:p>
+          <a:p>
+            <a:pPr lvl="1">
+              <a:spcAft>
+                <a:spcPts val="400"/>
+              </a:spcAft>
+              <a:defRPr sz="1700">
+                <a:solidFill>
+                  <a:srgbClr val="666666"/>
+                </a:solidFill>
+                <a:latin typeface="Calibri"/>
+              </a:defRPr>
+            </a:pPr>
+            <a:r>
+              <a:t>    Eficiente sin CouchDB — solo con LevelDB ya funciona.</a:t>
+            </a:r>
+          </a:p>
+        </p:txBody>
+      </p:sp>
+    </p:spTree>
+  </p:cSld>
+  <p:clrMapOvr>
+    <a:masterClrMapping/>
+  </p:clrMapOvr>
+</p:sld>
+</file>
+
+<file path=ppt/slides/slide26.xml><?xml version="1.0" encoding="utf-8"?>
+<p:sld xmlns:a="http://schemas.openxmlformats.org/drawingml/2006/main" xmlns:p="http://schemas.openxmlformats.org/presentationml/2006/main" xmlns:r="http://schemas.openxmlformats.org/officeDocument/2006/relationships">
+  <p:cSld>
+    <p:spTree>
+      <p:nvGrpSpPr>
+        <p:cNvPr id="1" name=""/>
+        <p:cNvGrpSpPr/>
+        <p:nvPr/>
+      </p:nvGrpSpPr>
+      <p:grpSpPr/>
+      <p:sp>
+        <p:nvSpPr>
+          <p:cNvPr id="2" name="Rectangle 1"/>
+          <p:cNvSpPr/>
+          <p:nvPr/>
+        </p:nvSpPr>
+        <p:spPr>
+          <a:xfrm>
+            <a:off x="0" y="0"/>
+            <a:ext cx="12188952" cy="73152"/>
+          </a:xfrm>
+          <a:prstGeom prst="rect">
+            <a:avLst/>
+          </a:prstGeom>
+          <a:solidFill>
+            <a:srgbClr val="22627E"/>
+          </a:solidFill>
+          <a:ln>
+            <a:noFill/>
+          </a:ln>
+        </p:spPr>
+        <p:style>
+          <a:lnRef idx="1">
+            <a:schemeClr val="accent1"/>
+          </a:lnRef>
+          <a:fillRef idx="3">
+            <a:schemeClr val="accent1"/>
+          </a:fillRef>
+          <a:effectRef idx="2">
+            <a:schemeClr val="accent1"/>
+          </a:effectRef>
+          <a:fontRef idx="minor">
+            <a:schemeClr val="lt1"/>
+          </a:fontRef>
+        </p:style>
+        <p:txBody>
+          <a:bodyPr rtlCol="0" anchor="ctr"/>
+          <a:lstStyle/>
+          <a:p>
+            <a:pPr algn="ctr"/>
+          </a:p>
+        </p:txBody>
+      </p:sp>
+      <p:sp>
+        <p:nvSpPr>
+          <p:cNvPr id="3" name="TextBox 2"/>
+          <p:cNvSpPr txBox="1"/>
+          <p:nvPr/>
+        </p:nvSpPr>
+        <p:spPr>
+          <a:xfrm>
+            <a:off x="457200" y="274320"/>
+            <a:ext cx="10972800" cy="731520"/>
+          </a:xfrm>
+          <a:prstGeom prst="rect">
+            <a:avLst/>
+          </a:prstGeom>
+          <a:noFill/>
+        </p:spPr>
+        <p:txBody>
+          <a:bodyPr wrap="square"/>
+          <a:lstStyle/>
+          <a:p>
+            <a:pPr algn="l">
+              <a:defRPr sz="3200" b="1">
+                <a:solidFill>
+                  <a:srgbClr val="22627E"/>
+                </a:solidFill>
+                <a:latin typeface="Calibri"/>
+              </a:defRPr>
+            </a:pPr>
+            <a:r>
+              <a:t>Respuestas al repaso (2/2)</a:t>
+            </a:r>
+          </a:p>
+        </p:txBody>
+      </p:sp>
+      <p:sp>
+        <p:nvSpPr>
+          <p:cNvPr id="4" name="Rectangle 3"/>
+          <p:cNvSpPr/>
+          <p:nvPr/>
+        </p:nvSpPr>
+        <p:spPr>
+          <a:xfrm>
+            <a:off x="457200" y="1051560"/>
+            <a:ext cx="10972800" cy="27432"/>
+          </a:xfrm>
+          <a:prstGeom prst="rect">
+            <a:avLst/>
+          </a:prstGeom>
+          <a:solidFill>
+            <a:srgbClr val="22627E"/>
+          </a:solidFill>
+          <a:ln>
+            <a:noFill/>
+          </a:ln>
+        </p:spPr>
+        <p:style>
+          <a:lnRef idx="1">
+            <a:schemeClr val="accent1"/>
+          </a:lnRef>
+          <a:fillRef idx="3">
+            <a:schemeClr val="accent1"/>
+          </a:fillRef>
+          <a:effectRef idx="2">
+            <a:schemeClr val="accent1"/>
+          </a:effectRef>
+          <a:fontRef idx="minor">
+            <a:schemeClr val="lt1"/>
+          </a:fontRef>
+        </p:style>
+        <p:txBody>
+          <a:bodyPr rtlCol="0" anchor="ctr"/>
+          <a:lstStyle/>
+          <a:p>
+            <a:pPr algn="ctr"/>
+          </a:p>
+        </p:txBody>
+      </p:sp>
+      <p:sp>
+        <p:nvSpPr>
+          <p:cNvPr id="5" name="TextBox 4"/>
+          <p:cNvSpPr txBox="1"/>
+          <p:nvPr/>
+        </p:nvSpPr>
+        <p:spPr>
+          <a:xfrm>
+            <a:off x="640080" y="1280160"/>
+            <a:ext cx="10515600" cy="5029200"/>
+          </a:xfrm>
+          <a:prstGeom prst="rect">
+            <a:avLst/>
+          </a:prstGeom>
+          <a:noFill/>
+        </p:spPr>
+        <p:txBody>
+          <a:bodyPr wrap="square">
+            <a:spAutoFit/>
+          </a:bodyPr>
+          <a:lstStyle/>
+          <a:p>
+            <a:pPr>
+              <a:spcAft>
+                <a:spcPts val="800"/>
+              </a:spcAft>
+              <a:defRPr sz="2000">
+                <a:solidFill>
+                  <a:srgbClr val="333333"/>
+                </a:solidFill>
+                <a:latin typeface="Calibri"/>
+              </a:defRPr>
+            </a:pPr>
+            <a:r>
+              <a:t>5. Flujo de trazabilidad de un lote alimentario:</a:t>
+            </a:r>
+          </a:p>
+          <a:p>
+            <a:pPr lvl="1">
+              <a:spcAft>
+                <a:spcPts val="400"/>
+              </a:spcAft>
+              <a:defRPr sz="1700">
+                <a:solidFill>
+                  <a:srgbClr val="666666"/>
+                </a:solidFill>
+                <a:latin typeface="Calibri"/>
+              </a:defRPr>
+            </a:pPr>
+            <a:r>
+              <a:t>    Produccion: ProductorMSP crea el lote con ProduceLot (origen, peso, tipo).</a:t>
+            </a:r>
+          </a:p>
+          <a:p>
+            <a:pPr lvl="1">
+              <a:spcAft>
+                <a:spcPts val="400"/>
+              </a:spcAft>
+              <a:defRPr sz="1700">
+                <a:solidFill>
+                  <a:srgbClr val="666666"/>
+                </a:solidFill>
+                <a:latin typeface="Calibri"/>
+              </a:defRPr>
+            </a:pPr>
+            <a:r>
+              <a:t>    Transito: TransferLot cambia el holder (con ubicacion y temperatura).</a:t>
+            </a:r>
+          </a:p>
+          <a:p>
+            <a:pPr lvl="1">
+              <a:spcAft>
+                <a:spcPts val="400"/>
+              </a:spcAft>
+              <a:defRPr sz="1700">
+                <a:solidFill>
+                  <a:srgbClr val="666666"/>
+                </a:solidFill>
+                <a:latin typeface="Calibri"/>
+              </a:defRPr>
+            </a:pPr>
+            <a:r>
+              <a:t>    Cada movimiento se anade al array 'history' del lote.</a:t>
+            </a:r>
+          </a:p>
+          <a:p>
+            <a:pPr lvl="1">
+              <a:spcAft>
+                <a:spcPts val="400"/>
+              </a:spcAft>
+              <a:defRPr sz="1700">
+                <a:solidFill>
+                  <a:srgbClr val="666666"/>
+                </a:solidFill>
+                <a:latin typeface="Calibri"/>
+              </a:defRPr>
+            </a:pPr>
+            <a:r>
+              <a:t>    Entrega: el ultimo holder marca UpdateStatus a 'delivered'.</a:t>
+            </a:r>
+          </a:p>
+          <a:p>
+            <a:pPr lvl="1">
+              <a:spcAft>
+                <a:spcPts val="400"/>
+              </a:spcAft>
+              <a:defRPr sz="1700">
+                <a:solidFill>
+                  <a:srgbClr val="666666"/>
+                </a:solidFill>
+                <a:latin typeface="Calibri"/>
+              </a:defRPr>
+            </a:pPr>
+            <a:r>
+              <a:t>    En cualquier momento: GetLotHistory devuelve toda la cadena de custodia.</a:t>
+            </a:r>
+          </a:p>
+          <a:p>
+            <a:pPr>
+              <a:spcAft>
+                <a:spcPts val="800"/>
+              </a:spcAft>
+              <a:defRPr sz="2000">
+                <a:solidFill>
+                  <a:srgbClr val="333333"/>
+                </a:solidFill>
+                <a:latin typeface="Calibri"/>
+              </a:defRPr>
+            </a:pPr>
+            <a:r>
+              <a:t>6. Quien puede hacer recall y por que:</a:t>
+            </a:r>
+          </a:p>
+          <a:p>
+            <a:pPr lvl="1">
+              <a:spcAft>
+                <a:spcPts val="400"/>
+              </a:spcAft>
+              <a:defRPr sz="1700">
+                <a:solidFill>
+                  <a:srgbClr val="666666"/>
+                </a:solidFill>
+                <a:latin typeface="Calibri"/>
+              </a:defRPr>
+            </a:pPr>
+            <a:r>
+              <a:t>    Solo el regulador (role=regulador via ABAC en el certificado X.509).</a:t>
+            </a:r>
+          </a:p>
+          <a:p>
+            <a:pPr lvl="1">
+              <a:spcAft>
+                <a:spcPts val="400"/>
+              </a:spcAft>
+              <a:defRPr sz="1700">
+                <a:solidFill>
+                  <a:srgbClr val="666666"/>
+                </a:solidFill>
+                <a:latin typeface="Calibri"/>
+              </a:defRPr>
+            </a:pPr>
+            <a:r>
+              <a:t>    Razon: el recall tiene implicaciones legales y sanitarias — no cualquiera decide retirar del mercado.</a:t>
+            </a:r>
+          </a:p>
+          <a:p>
+            <a:pPr lvl="1">
+              <a:spcAft>
+                <a:spcPts val="400"/>
+              </a:spcAft>
+              <a:defRPr sz="1700">
+                <a:solidFill>
+                  <a:srgbClr val="666666"/>
+                </a:solidFill>
+                <a:latin typeface="Calibri"/>
+              </a:defRPr>
+            </a:pPr>
+            <a:r>
+              <a:t>    En produccion: AESAN (Espana), FDA (USA), EFSA (UE) tendrian este rol.</a:t>
+            </a:r>
+          </a:p>
+          <a:p>
+            <a:pPr lvl="1">
+              <a:spcAft>
+                <a:spcPts val="400"/>
+              </a:spcAft>
+              <a:defRPr sz="1700">
+                <a:solidFill>
+                  <a:srgbClr val="666666"/>
+                </a:solidFill>
+                <a:latin typeface="Calibri"/>
+              </a:defRPr>
+            </a:pPr>
+            <a:r>
+              <a:t>    El recall cambia status a 'recalled' y emite evento para notificar a todos los actores.</a:t>
+            </a:r>
+          </a:p>
+          <a:p>
+            <a:pPr lvl="1">
+              <a:spcAft>
+                <a:spcPts val="400"/>
+              </a:spcAft>
+              <a:defRPr sz="1700">
+                <a:solidFill>
+                  <a:srgbClr val="666666"/>
+                </a:solidFill>
+                <a:latin typeface="Calibri"/>
+              </a:defRPr>
+            </a:pPr>
+            <a:r>
+              <a:t>    Tras recall: el lote ya no se puede transferir, solo investigar y destruir.</a:t>
+            </a:r>
+          </a:p>
+          <a:p>
+            <a:pPr>
+              <a:spcAft>
+                <a:spcPts val="800"/>
+              </a:spcAft>
+              <a:defRPr sz="2000">
+                <a:solidFill>
+                  <a:srgbClr val="333333"/>
+                </a:solidFill>
+                <a:latin typeface="Calibri"/>
+              </a:defRPr>
+            </a:pPr>
+            <a:r>
+              <a:t>7. Registrar el historial de movimientos:</a:t>
+            </a:r>
+          </a:p>
+          <a:p>
+            <a:pPr lvl="1">
+              <a:spcAft>
+                <a:spcPts val="400"/>
+              </a:spcAft>
+              <a:defRPr sz="1700">
+                <a:solidFill>
+                  <a:srgbClr val="666666"/>
+                </a:solidFill>
+                <a:latin typeface="Calibri"/>
+              </a:defRPr>
+            </a:pPr>
+            <a:r>
+              <a:t>    Array de HistEntry dentro del objeto FoodLot (serializado como JSON).</a:t>
+            </a:r>
+          </a:p>
+          <a:p>
+            <a:pPr lvl="1">
+              <a:spcAft>
+                <a:spcPts val="400"/>
+              </a:spcAft>
+              <a:defRPr sz="1700">
+                <a:solidFill>
+                  <a:srgbClr val="666666"/>
+                </a:solidFill>
+                <a:latin typeface="Calibri"/>
+              </a:defRPr>
+            </a:pPr>
+            <a:r>
+              <a:t>    Cada entrada: org, action, timestamp (determinista), location.</a:t>
+            </a:r>
+          </a:p>
+          <a:p>
+            <a:pPr lvl="1">
+              <a:spcAft>
+                <a:spcPts val="400"/>
+              </a:spcAft>
+              <a:defRPr sz="1700">
+                <a:solidFill>
+                  <a:srgbClr val="666666"/>
+                </a:solidFill>
+                <a:latin typeface="Calibri"/>
+              </a:defRPr>
+            </a:pPr>
+            <a:r>
+              <a:t>    Se va anadiendo en cada operacion (Produce, Transfer, Recall, Deliver).</a:t>
+            </a:r>
+          </a:p>
+          <a:p>
+            <a:pPr lvl="1">
+              <a:spcAft>
+                <a:spcPts val="400"/>
+              </a:spcAft>
+              <a:defRPr sz="1700">
+                <a:solidFill>
+                  <a:srgbClr val="666666"/>
+                </a:solidFill>
+                <a:latin typeface="Calibri"/>
+              </a:defRPr>
+            </a:pPr>
+            <a:r>
+              <a:t>    Al ser parte del propio lote, se preserva al hacer updates.</a:t>
+            </a:r>
+          </a:p>
+          <a:p>
+            <a:pPr lvl="1">
+              <a:spcAft>
+                <a:spcPts val="400"/>
+              </a:spcAft>
+              <a:defRPr sz="1700">
+                <a:solidFill>
+                  <a:srgbClr val="666666"/>
+                </a:solidFill>
+                <a:latin typeface="Calibri"/>
+              </a:defRPr>
+            </a:pPr>
+            <a:r>
+              <a:t>    Alternativa: usar GetHistoryForKey para el historial de cambios de la propia key.</a:t>
             </a:r>
           </a:p>
         </p:txBody>

</xml_diff>